<commit_message>
Narrow Rye Law proposal to Elite Coach Plus only
Per Slack request: drop Full Service Marketing — Starter from the
immediate recommendation across the audit report, proposal PPTX, and
sales companion. Elite Coach Plus ($3,200/mo) is now the sole package;
marketing is retained as a Phase 2 roadmap upsell. Total investment
drops from $4,997/mo to $3,200/mo.
</commit_message>
<xml_diff>
--- a/rye-law/Rye Law_August 5, 2026_Proposal.pptx
+++ b/rye-law/Rye Law_August 5, 2026_Proposal.pptx
@@ -8709,7 +8709,7 @@
             <a:avLst/>
           </a:prstGeom>
           <a:solidFill>
-            <a:srgbClr val="1D4ED8"/>
+            <a:srgbClr val="6D28D9"/>
           </a:solidFill>
           <a:ln>
             <a:solidFill>
@@ -8763,11 +8763,11 @@
             <a:r>
               <a:rPr sz="800" b="1" i="0">
                 <a:solidFill>
-                  <a:srgbClr val="1D4ED8"/>
+                  <a:srgbClr val="6D28D9"/>
                 </a:solidFill>
                 <a:latin typeface="Calibri"/>
               </a:rPr>
-              <a:t>FULL SERVICE MARKETING — STARTER</a:t>
+              <a:t>ELITE COACH PLUS</a:t>
             </a:r>
           </a:p>
         </p:txBody>
@@ -8800,7 +8800,7 @@
                 </a:solidFill>
                 <a:latin typeface="Calibri"/>
               </a:rPr>
-              <a:t>$4,997</a:t>
+              <a:t>$3,200</a:t>
             </a:r>
           </a:p>
         </p:txBody>
@@ -8866,7 +8866,7 @@
                 </a:solidFill>
                 <a:latin typeface="Calibri"/>
               </a:rPr>
-              <a:t>$5,697/mo</a:t>
+              <a:t>$3,497/mo</a:t>
             </a:r>
           </a:p>
         </p:txBody>
@@ -8944,7 +8944,7 @@
                 </a:solidFill>
                 <a:latin typeface="Calibri"/>
               </a:rPr>
-              <a:t>Google Ads · Meta Ads · Local SEO · Website · GBP</a:t>
+              <a:t>Weekly Coaching · Delegation Frameworks · Financial Visibility · Masterminds</a:t>
             </a:r>
           </a:p>
         </p:txBody>
@@ -9055,7 +9055,7 @@
                 </a:solidFill>
                 <a:latin typeface="Calibri"/>
               </a:rPr>
-              <a:t>$4,997 / mo</a:t>
+              <a:t>$3,200 / mo</a:t>
             </a:r>
           </a:p>
         </p:txBody>
@@ -9088,7 +9088,7 @@
                 </a:solidFill>
                 <a:latin typeface="Calibri"/>
               </a:rPr>
-              <a:t>Save $700/mo vs. stand-alone pricing</a:t>
+              <a:t>Save $297/mo vs. stand-alone pricing</a:t>
             </a:r>
           </a:p>
         </p:txBody>
@@ -9166,7 +9166,7 @@
                 </a:solidFill>
                 <a:latin typeface="Calibri"/>
               </a:rPr>
-              <a:t>+ Recommended ad spend: $3,500–$11,500/mo paid directly to Google/Meta</a:t>
+              <a:t>Marketing and ad spend are not part of this initial engagement — revisited once the leadership structure is in place.</a:t>
             </a:r>
           </a:p>
         </p:txBody>
@@ -9244,7 +9244,7 @@
                 </a:solidFill>
                 <a:latin typeface="Calibri"/>
               </a:rPr>
-              <a:t>PROJECTED RETURN ON AD SPEND</a:t>
+              <a:t>WHAT ELITE COACH PLUS DELIVERS</a:t>
             </a:r>
           </a:p>
         </p:txBody>
@@ -9277,7 +9277,7 @@
                 </a:solidFill>
                 <a:latin typeface="Calibri"/>
               </a:rPr>
-              <a:t>Average case value:</a:t>
+              <a:t>Coaching cadence:</a:t>
             </a:r>
           </a:p>
         </p:txBody>
@@ -9310,7 +9310,7 @@
                 </a:solidFill>
                 <a:latin typeface="Calibri"/>
               </a:rPr>
-              <a:t>$4,700 (blended)</a:t>
+              <a:t>Dedicated SMB Team coach</a:t>
             </a:r>
           </a:p>
         </p:txBody>
@@ -9388,7 +9388,7 @@
                 </a:solidFill>
                 <a:latin typeface="Calibri"/>
               </a:rPr>
-              <a:t>Conservative  (4 cases/mo):</a:t>
+              <a:t>Delegation framework:</a:t>
             </a:r>
           </a:p>
         </p:txBody>
@@ -9421,7 +9421,7 @@
                 </a:solidFill>
                 <a:latin typeface="Calibri"/>
               </a:rPr>
-              <a:t>$18,800 revenue · 5.4× ROAS</a:t>
+              <a:t>Built for 3 clerks + bookkeeper</a:t>
             </a:r>
           </a:p>
         </p:txBody>
@@ -9454,7 +9454,7 @@
                 </a:solidFill>
                 <a:latin typeface="Calibri"/>
               </a:rPr>
-              <a:t>Aggressive  (16 cases/mo):</a:t>
+              <a:t>Financial visibility:</a:t>
             </a:r>
           </a:p>
         </p:txBody>
@@ -9487,7 +9487,7 @@
                 </a:solidFill>
                 <a:latin typeface="Calibri"/>
               </a:rPr>
-              <a:t>$75,200 revenue · 6.5× ROAS</a:t>
+              <a:t>AR &amp; expense cycle mapped</a:t>
             </a:r>
           </a:p>
         </p:txBody>
@@ -9598,7 +9598,7 @@
                 </a:solidFill>
                 <a:latin typeface="Calibri"/>
               </a:rPr>
-              <a:t>Day 1</a:t>
+              <a:t>Week 1</a:t>
             </a:r>
           </a:p>
         </p:txBody>
@@ -9631,7 +9631,7 @@
                 </a:solidFill>
                 <a:latin typeface="Calibri"/>
               </a:rPr>
-              <a:t>Google Ads live for immigration &amp; family law</a:t>
+              <a:t>Weekly coaching sessions &amp; mastermind enrollment begin</a:t>
             </a:r>
           </a:p>
         </p:txBody>
@@ -9709,7 +9709,7 @@
                 </a:solidFill>
                 <a:latin typeface="Calibri"/>
               </a:rPr>
-              <a:t>Day 14</a:t>
+              <a:t>Weeks 2-4</a:t>
             </a:r>
           </a:p>
         </p:txBody>
@@ -9742,7 +9742,7 @@
                 </a:solidFill>
                 <a:latin typeface="Calibri"/>
               </a:rPr>
-              <a:t>Native contact form replaces the JotForm</a:t>
+              <a:t>Delegation framework drafted for clerks &amp; bookkeeper</a:t>
             </a:r>
           </a:p>
         </p:txBody>
@@ -9820,7 +9820,7 @@
                 </a:solidFill>
                 <a:latin typeface="Calibri"/>
               </a:rPr>
-              <a:t>Week 2</a:t>
+              <a:t>Weeks 1-4</a:t>
             </a:r>
           </a:p>
         </p:txBody>
@@ -9853,7 +9853,7 @@
                 </a:solidFill>
                 <a:latin typeface="Calibri"/>
               </a:rPr>
-              <a:t>GBP verified, review generation begins</a:t>
+              <a:t>Financial visibility work starts on AR &amp; expense cycle</a:t>
             </a:r>
           </a:p>
         </p:txBody>
@@ -9931,7 +9931,7 @@
                 </a:solidFill>
                 <a:latin typeface="Calibri"/>
               </a:rPr>
-              <a:t>Week 3</a:t>
+              <a:t>Month 1-2</a:t>
             </a:r>
           </a:p>
         </p:txBody>
@@ -9964,7 +9964,7 @@
                 </a:solidFill>
                 <a:latin typeface="Calibri"/>
               </a:rPr>
-              <a:t>Lead follow-up sequence goes live</a:t>
+              <a:t>Outstanding AR collection runs in parallel</a:t>
             </a:r>
           </a:p>
         </p:txBody>
@@ -10042,7 +10042,7 @@
                 </a:solidFill>
                 <a:latin typeface="Calibri"/>
               </a:rPr>
-              <a:t>Month 3</a:t>
+              <a:t>Month 2-3</a:t>
             </a:r>
           </a:p>
         </p:txBody>
@@ -10075,7 +10075,7 @@
                 </a:solidFill>
                 <a:latin typeface="Calibri"/>
               </a:rPr>
-              <a:t>Meta retargeting layers on existing audience</a:t>
+              <a:t>First profit-plan groundwork laid across all 5 practice areas</a:t>
             </a:r>
           </a:p>
         </p:txBody>

</xml_diff>